<commit_message>
creating new file for continuing database exploration setting up file tree in advance for early organization
</commit_message>
<xml_diff>
--- a/AABA-Poster/GM-AABA2026Poster-LifeHistoryDatabases.pptx
+++ b/AABA-Poster/GM-AABA2026Poster-LifeHistoryDatabases.pptx
@@ -249,7 +249,7 @@
           <a:p>
             <a:fld id="{0E19EFA1-6199-496A-BC1D-DE705E3EBA0B}" type="datetimeFigureOut">
               <a:rPr lang="en-US" smtClean="0"/>
-              <a:t>3/16/2026</a:t>
+              <a:t>3/25/2026</a:t>
             </a:fld>
             <a:endParaRPr lang="en-US"/>
           </a:p>
@@ -419,7 +419,7 @@
           <a:p>
             <a:fld id="{0E19EFA1-6199-496A-BC1D-DE705E3EBA0B}" type="datetimeFigureOut">
               <a:rPr lang="en-US" smtClean="0"/>
-              <a:t>3/16/2026</a:t>
+              <a:t>3/25/2026</a:t>
             </a:fld>
             <a:endParaRPr lang="en-US"/>
           </a:p>
@@ -599,7 +599,7 @@
           <a:p>
             <a:fld id="{0E19EFA1-6199-496A-BC1D-DE705E3EBA0B}" type="datetimeFigureOut">
               <a:rPr lang="en-US" smtClean="0"/>
-              <a:t>3/16/2026</a:t>
+              <a:t>3/25/2026</a:t>
             </a:fld>
             <a:endParaRPr lang="en-US"/>
           </a:p>
@@ -769,7 +769,7 @@
           <a:p>
             <a:fld id="{0E19EFA1-6199-496A-BC1D-DE705E3EBA0B}" type="datetimeFigureOut">
               <a:rPr lang="en-US" smtClean="0"/>
-              <a:t>3/16/2026</a:t>
+              <a:t>3/25/2026</a:t>
             </a:fld>
             <a:endParaRPr lang="en-US"/>
           </a:p>
@@ -1015,7 +1015,7 @@
           <a:p>
             <a:fld id="{0E19EFA1-6199-496A-BC1D-DE705E3EBA0B}" type="datetimeFigureOut">
               <a:rPr lang="en-US" smtClean="0"/>
-              <a:t>3/16/2026</a:t>
+              <a:t>3/25/2026</a:t>
             </a:fld>
             <a:endParaRPr lang="en-US"/>
           </a:p>
@@ -1247,7 +1247,7 @@
           <a:p>
             <a:fld id="{0E19EFA1-6199-496A-BC1D-DE705E3EBA0B}" type="datetimeFigureOut">
               <a:rPr lang="en-US" smtClean="0"/>
-              <a:t>3/16/2026</a:t>
+              <a:t>3/25/2026</a:t>
             </a:fld>
             <a:endParaRPr lang="en-US"/>
           </a:p>
@@ -1614,7 +1614,7 @@
           <a:p>
             <a:fld id="{0E19EFA1-6199-496A-BC1D-DE705E3EBA0B}" type="datetimeFigureOut">
               <a:rPr lang="en-US" smtClean="0"/>
-              <a:t>3/16/2026</a:t>
+              <a:t>3/25/2026</a:t>
             </a:fld>
             <a:endParaRPr lang="en-US"/>
           </a:p>
@@ -1732,7 +1732,7 @@
           <a:p>
             <a:fld id="{0E19EFA1-6199-496A-BC1D-DE705E3EBA0B}" type="datetimeFigureOut">
               <a:rPr lang="en-US" smtClean="0"/>
-              <a:t>3/16/2026</a:t>
+              <a:t>3/25/2026</a:t>
             </a:fld>
             <a:endParaRPr lang="en-US"/>
           </a:p>
@@ -1827,7 +1827,7 @@
           <a:p>
             <a:fld id="{0E19EFA1-6199-496A-BC1D-DE705E3EBA0B}" type="datetimeFigureOut">
               <a:rPr lang="en-US" smtClean="0"/>
-              <a:t>3/16/2026</a:t>
+              <a:t>3/25/2026</a:t>
             </a:fld>
             <a:endParaRPr lang="en-US"/>
           </a:p>
@@ -2104,7 +2104,7 @@
           <a:p>
             <a:fld id="{0E19EFA1-6199-496A-BC1D-DE705E3EBA0B}" type="datetimeFigureOut">
               <a:rPr lang="en-US" smtClean="0"/>
-              <a:t>3/16/2026</a:t>
+              <a:t>3/25/2026</a:t>
             </a:fld>
             <a:endParaRPr lang="en-US"/>
           </a:p>
@@ -2361,7 +2361,7 @@
           <a:p>
             <a:fld id="{0E19EFA1-6199-496A-BC1D-DE705E3EBA0B}" type="datetimeFigureOut">
               <a:rPr lang="en-US" smtClean="0"/>
-              <a:t>3/16/2026</a:t>
+              <a:t>3/25/2026</a:t>
             </a:fld>
             <a:endParaRPr lang="en-US"/>
           </a:p>
@@ -2574,7 +2574,7 @@
           <a:p>
             <a:fld id="{0E19EFA1-6199-496A-BC1D-DE705E3EBA0B}" type="datetimeFigureOut">
               <a:rPr lang="en-US" smtClean="0"/>
-              <a:t>3/16/2026</a:t>
+              <a:t>3/25/2026</a:t>
             </a:fld>
             <a:endParaRPr lang="en-US"/>
           </a:p>
@@ -6290,14 +6290,14 @@
           <p:nvPr>
             <p:extLst>
               <p:ext uri="{D42A27DB-BD31-4B8C-83A1-F6EECF244321}">
-                <p14:modId xmlns:p14="http://schemas.microsoft.com/office/powerpoint/2010/main" val="208697180"/>
+                <p14:modId xmlns:p14="http://schemas.microsoft.com/office/powerpoint/2010/main" val="141022189"/>
               </p:ext>
             </p:extLst>
           </p:nvPr>
         </p:nvGraphicFramePr>
         <p:xfrm>
-          <a:off x="13649080" y="34537984"/>
-          <a:ext cx="15378453" cy="3535680"/>
+          <a:off x="13541711" y="34537984"/>
+          <a:ext cx="15639622" cy="3535680"/>
         </p:xfrm>
         <a:graphic>
           <a:graphicData uri="http://schemas.openxmlformats.org/drawingml/2006/table">
@@ -6306,28 +6306,28 @@
                 <a:tableStyleId>{5C22544A-7EE6-4342-B048-85BDC9FD1C3A}</a:tableStyleId>
               </a:tblPr>
               <a:tblGrid>
-                <a:gridCol w="2673708">
+                <a:gridCol w="2719115">
                   <a:extLst>
                     <a:ext uri="{9D8B030D-6E8A-4147-A177-3AD203B41FA5}">
                       <a16:colId xmlns:a16="http://schemas.microsoft.com/office/drawing/2014/main" val="2953196259"/>
                     </a:ext>
                   </a:extLst>
                 </a:gridCol>
-                <a:gridCol w="1800901">
+                <a:gridCol w="1831485">
                   <a:extLst>
                     <a:ext uri="{9D8B030D-6E8A-4147-A177-3AD203B41FA5}">
                       <a16:colId xmlns:a16="http://schemas.microsoft.com/office/drawing/2014/main" val="2850544499"/>
                     </a:ext>
                   </a:extLst>
                 </a:gridCol>
-                <a:gridCol w="4718594">
+                <a:gridCol w="4065234">
                   <a:extLst>
                     <a:ext uri="{9D8B030D-6E8A-4147-A177-3AD203B41FA5}">
                       <a16:colId xmlns:a16="http://schemas.microsoft.com/office/drawing/2014/main" val="3719952992"/>
                     </a:ext>
                   </a:extLst>
                 </a:gridCol>
-                <a:gridCol w="6185250">
+                <a:gridCol w="7023788">
                   <a:extLst>
                     <a:ext uri="{9D8B030D-6E8A-4147-A177-3AD203B41FA5}">
                       <a16:colId xmlns:a16="http://schemas.microsoft.com/office/drawing/2014/main" val="569871792"/>
@@ -6474,7 +6474,7 @@
                     <a:p>
                       <a:r>
                         <a:rPr lang="en-US" sz="2600" b="0" dirty="0"/>
-                        <a:t>[2] defines as eating solid food, [7] as first solid food OR last nursing</a:t>
+                        <a:t>Ernest [6] defines as eating solid food, PanTHERIA [9] as first solid food OR last nursing</a:t>
                       </a:r>
                     </a:p>
                   </a:txBody>
@@ -6550,7 +6550,7 @@
                     <a:p>
                       <a:r>
                         <a:rPr lang="en-US" sz="2600" b="0" dirty="0"/>
-                        <a:t>[2] records litters/year, [7] specifies between successful births</a:t>
+                        <a:t>Ernest [6] records litters/year, PanTHERIA [9] specifies between successful births</a:t>
                       </a:r>
                     </a:p>
                   </a:txBody>
@@ -6626,7 +6626,7 @@
                     <a:p>
                       <a:r>
                         <a:rPr lang="en-US" sz="2600" b="0" dirty="0"/>
-                        <a:t>[2] specifies live offspring, [7] specifies “non-inactive” fetal growth</a:t>
+                        <a:t>Ernest [6] specifies live offspring, PanTHERIA [9] specifies “non-inactive” fetal growth</a:t>
                       </a:r>
                     </a:p>
                   </a:txBody>

</xml_diff>

<commit_message>
updated R studio, formatting changes in update require new save
</commit_message>
<xml_diff>
--- a/AABA-Poster/GM-AABA2026Poster-LifeHistoryDatabases.pptx
+++ b/AABA-Poster/GM-AABA2026Poster-LifeHistoryDatabases.pptx
@@ -249,7 +249,7 @@
           <a:p>
             <a:fld id="{0E19EFA1-6199-496A-BC1D-DE705E3EBA0B}" type="datetimeFigureOut">
               <a:rPr lang="en-US" smtClean="0"/>
-              <a:t>3/25/2026</a:t>
+              <a:t>4/19/2026</a:t>
             </a:fld>
             <a:endParaRPr lang="en-US"/>
           </a:p>
@@ -419,7 +419,7 @@
           <a:p>
             <a:fld id="{0E19EFA1-6199-496A-BC1D-DE705E3EBA0B}" type="datetimeFigureOut">
               <a:rPr lang="en-US" smtClean="0"/>
-              <a:t>3/25/2026</a:t>
+              <a:t>4/19/2026</a:t>
             </a:fld>
             <a:endParaRPr lang="en-US"/>
           </a:p>
@@ -599,7 +599,7 @@
           <a:p>
             <a:fld id="{0E19EFA1-6199-496A-BC1D-DE705E3EBA0B}" type="datetimeFigureOut">
               <a:rPr lang="en-US" smtClean="0"/>
-              <a:t>3/25/2026</a:t>
+              <a:t>4/19/2026</a:t>
             </a:fld>
             <a:endParaRPr lang="en-US"/>
           </a:p>
@@ -769,7 +769,7 @@
           <a:p>
             <a:fld id="{0E19EFA1-6199-496A-BC1D-DE705E3EBA0B}" type="datetimeFigureOut">
               <a:rPr lang="en-US" smtClean="0"/>
-              <a:t>3/25/2026</a:t>
+              <a:t>4/19/2026</a:t>
             </a:fld>
             <a:endParaRPr lang="en-US"/>
           </a:p>
@@ -1015,7 +1015,7 @@
           <a:p>
             <a:fld id="{0E19EFA1-6199-496A-BC1D-DE705E3EBA0B}" type="datetimeFigureOut">
               <a:rPr lang="en-US" smtClean="0"/>
-              <a:t>3/25/2026</a:t>
+              <a:t>4/19/2026</a:t>
             </a:fld>
             <a:endParaRPr lang="en-US"/>
           </a:p>
@@ -1247,7 +1247,7 @@
           <a:p>
             <a:fld id="{0E19EFA1-6199-496A-BC1D-DE705E3EBA0B}" type="datetimeFigureOut">
               <a:rPr lang="en-US" smtClean="0"/>
-              <a:t>3/25/2026</a:t>
+              <a:t>4/19/2026</a:t>
             </a:fld>
             <a:endParaRPr lang="en-US"/>
           </a:p>
@@ -1614,7 +1614,7 @@
           <a:p>
             <a:fld id="{0E19EFA1-6199-496A-BC1D-DE705E3EBA0B}" type="datetimeFigureOut">
               <a:rPr lang="en-US" smtClean="0"/>
-              <a:t>3/25/2026</a:t>
+              <a:t>4/19/2026</a:t>
             </a:fld>
             <a:endParaRPr lang="en-US"/>
           </a:p>
@@ -1732,7 +1732,7 @@
           <a:p>
             <a:fld id="{0E19EFA1-6199-496A-BC1D-DE705E3EBA0B}" type="datetimeFigureOut">
               <a:rPr lang="en-US" smtClean="0"/>
-              <a:t>3/25/2026</a:t>
+              <a:t>4/19/2026</a:t>
             </a:fld>
             <a:endParaRPr lang="en-US"/>
           </a:p>
@@ -1827,7 +1827,7 @@
           <a:p>
             <a:fld id="{0E19EFA1-6199-496A-BC1D-DE705E3EBA0B}" type="datetimeFigureOut">
               <a:rPr lang="en-US" smtClean="0"/>
-              <a:t>3/25/2026</a:t>
+              <a:t>4/19/2026</a:t>
             </a:fld>
             <a:endParaRPr lang="en-US"/>
           </a:p>
@@ -2104,7 +2104,7 @@
           <a:p>
             <a:fld id="{0E19EFA1-6199-496A-BC1D-DE705E3EBA0B}" type="datetimeFigureOut">
               <a:rPr lang="en-US" smtClean="0"/>
-              <a:t>3/25/2026</a:t>
+              <a:t>4/19/2026</a:t>
             </a:fld>
             <a:endParaRPr lang="en-US"/>
           </a:p>
@@ -2361,7 +2361,7 @@
           <a:p>
             <a:fld id="{0E19EFA1-6199-496A-BC1D-DE705E3EBA0B}" type="datetimeFigureOut">
               <a:rPr lang="en-US" smtClean="0"/>
-              <a:t>3/25/2026</a:t>
+              <a:t>4/19/2026</a:t>
             </a:fld>
             <a:endParaRPr lang="en-US"/>
           </a:p>
@@ -2574,7 +2574,7 @@
           <a:p>
             <a:fld id="{0E19EFA1-6199-496A-BC1D-DE705E3EBA0B}" type="datetimeFigureOut">
               <a:rPr lang="en-US" smtClean="0"/>
-              <a:t>3/25/2026</a:t>
+              <a:t>4/19/2026</a:t>
             </a:fld>
             <a:endParaRPr lang="en-US"/>
           </a:p>
@@ -5163,7 +5163,7 @@
           <p:nvPr>
             <p:extLst>
               <p:ext uri="{D42A27DB-BD31-4B8C-83A1-F6EECF244321}">
-                <p14:modId xmlns:p14="http://schemas.microsoft.com/office/powerpoint/2010/main" val="1761672090"/>
+                <p14:modId xmlns:p14="http://schemas.microsoft.com/office/powerpoint/2010/main" val="2735832707"/>
               </p:ext>
             </p:extLst>
           </p:nvPr>
@@ -5830,7 +5830,7 @@
                           <a:latin typeface="Arial" panose="020B0604020202020204" pitchFamily="34" charset="0"/>
                           <a:cs typeface="Arial" panose="020B0604020202020204" pitchFamily="34" charset="0"/>
                         </a:rPr>
-                        <a:t>.31</a:t>
+                        <a:t>.28</a:t>
                       </a:r>
                     </a:p>
                   </a:txBody>
@@ -5977,7 +5977,7 @@
                           <a:latin typeface="Arial" panose="020B0604020202020204" pitchFamily="34" charset="0"/>
                           <a:cs typeface="Arial" panose="020B0604020202020204" pitchFamily="34" charset="0"/>
                         </a:rPr>
-                        <a:t>.69</a:t>
+                        <a:t>.66</a:t>
                       </a:r>
                     </a:p>
                   </a:txBody>

</xml_diff>